<commit_message>
Sweep remaining old-framing wording (notes, setup guide, brief)
Align supporting text with the questions-as-lens positioning: speaker
notes ("discuss how it answers adaptive-control questions",
"control-perspective comparison", "compare each mechanism with the
question it echoes"), the setup-guide phase row (Control perspective),
and the design brief's framing language (Phase 3, RQ3, closing example,
preferred wording). Visible slide content and README were already clean.

https://claude.ai/code/session_015i3CJw2uiqwwXT61q7nN5g
</commit_message>
<xml_diff>
--- a/docs/20260525_progress_report_v1.pptx
+++ b/docs/20260525_progress_report_v1.pptx
@@ -508,7 +508,7 @@
               <a:rPr lang="en-US" dirty="0"/>
               <a:t>[~10 sec]
 Open: title, course, your name — one breath, then move on.
-CORE (set the frame early): We are NOT proposing a new controller. We reproduce SATA, understand its adaptive behavior, and discuss it from a control perspective.
+CORE (set the frame early): We are NOT proposing a new controller. We reproduce SATA, understand its adaptive behavior, and discuss how it answers adaptive-control questions.
 TRANSITION: 'Let me start with why this is a control problem.'</a:t>
             </a:r>
             <a:endParaRPr lang="en-US" dirty="0"/>
@@ -598,7 +598,7 @@
             <a:r>
               <a:rPr lang="en-US" dirty="0"/>
               <a:t>[~40 sec]
-CORE MESSAGE (repeat across the talk): We are NOT proposing a new controller. We aim to reproduce SATA, understand its adaptive behavior, and discuss it from a control perspective.
+CORE MESSAGE (repeat across the talk): We are NOT proposing a new controller. We aim to reproduce SATA, understand its adaptive behavior, and discuss how it answers adaptive-control questions.
 TALKING POINTS:
 - Frame this as a CONTROL problem, not an RL talk.
 - Position control commands a joint angle; a low-level PD loop turns the error into torque. Stiff and accurate when the world is known.
@@ -792,7 +792,7 @@
 - Feasibility is the point of this slide: executable, not just a paper review.
 - Phase 1: stand up the official SATA pipeline in Isaac Gym — proves we can run it.
 - Phase 2: controlled ablations — toggle fatigue, retune torque limit / growth, change terrain; observe behavior shifts.
-- Phase 3: map each mechanism to an adaptive-control reading (analogy, not equivalence).
+- Phase 3: compare each mechanism with the adaptive-control question it echoes (analogy, not equivalence).
 - Phase 4 residual term only if time allows — not promised.
 TRANSITION: 'So what do we expect to deliver?'</a:t>
             </a:r>
@@ -885,10 +885,10 @@
               <a:t>[~30 sec]
 TALKING POINTS:
 - Close the loop, no overclaiming: the contribution is understanding, not a new algorithm.
-- Three concrete outputs: reproduction, behavior analysis, control-theoretic interpretation.
+- Three concrete outputs: reproduction, behavior analysis, control-perspective comparison.
 - The four research questions map onto the four slides.
-CLOSING LINE (read the bottom band): bio-inspired torque control -&gt; adaptive behavior -&gt; interpreted through adaptive &amp; robust control.
-REINFORCE THE CORE: we are not proposing a new controller — reproduce SATA, understand its adaptive behavior, discuss it from a control perspective.
+CLOSING LINE (read the bottom band): bio-inspired torque control -&gt; adaptive behavior -&gt; answers questions posed by adaptive &amp; robust control.
+REINFORCE THE CORE: we are not proposing a new controller — reproduce SATA, understand its adaptive behavior, discuss how it answers adaptive-control questions.
 TRANSITION: 'Happy to take questions.'</a:t>
             </a:r>
             <a:endParaRPr lang="en-US" dirty="0"/>

</xml_diff>

<commit_message>
Differentiate slide 3 band from slide 4 banner
Slide 3 and 4 both said "study adaptation, not a new RL algorithm".
Repoint slide 3's bottom band to the unique questions-as-lens framing
("Adaptive control supplies the questions; SATA offers a different kind
of answer"), and keep slide 4's banner as the non-novelty statement.

https://claude.ai/code/session_015i3CJw2uiqwwXT61q7nN5g
</commit_message>
<xml_diff>
--- a/docs/20260525_progress_report_v1.pptx
+++ b/docs/20260525_progress_report_v1.pptx
@@ -6792,7 +6792,7 @@
                 <a:ea typeface="Calibri" pitchFamily="34" charset="-122"/>
                 <a:cs typeface="Calibri" pitchFamily="34" charset="-120"/>
               </a:rPr>
-              <a:t>APPROACH</a:t>
+              <a:t>FRAMING</a:t>
             </a:r>
             <a:endParaRPr lang="en-US" sz="1100" dirty="0"/>
           </a:p>
@@ -6831,7 +6831,7 @@
                 <a:ea typeface="Georgia" pitchFamily="34" charset="-122"/>
                 <a:cs typeface="Georgia" pitchFamily="34" charset="-120"/>
               </a:rPr>
-              <a:t>We analyze adaptation instead of proposing new methods — we do not redesign the RL algorithm.</a:t>
+              <a:t>Adaptive control supplies the questions; SATA offers a different kind of answer.</a:t>
             </a:r>
             <a:endParaRPr lang="en-US" sz="1550" dirty="0"/>
           </a:p>

</xml_diff>